<commit_message>
feat(it-inventory,shared,f2s): backup current frontend before implementing PIA 1.6 updates
- i18n multi-language support (en, vi, id, km, th) for IT Inventory & shared components
- StatusDetailModal for showing details
- usePageVisible path fix & event listeners
- Logs page UI and search improvements
- f2s-delivery Excel column filters and delivery scanning improvements
</commit_message>
<xml_diff>
--- a/TraxEco_IT_Inventory_Customs_EN.pptx
+++ b/TraxEco_IT_Inventory_Customs_EN.pptx
@@ -113,6 +113,1175 @@
     </a:lvl9pPr>
   </p:defaultTextStyle>
 </p:presentation>
+</file>
+
+<file path=ppt/notesMasters/notesMaster1.xml><?xml version="1.0" encoding="utf-8"?>
+<p:notesMaster xmlns:a="http://schemas.openxmlformats.org/drawingml/2006/main" xmlns:p="http://schemas.openxmlformats.org/presentationml/2006/main" xmlns:r="http://schemas.openxmlformats.org/officeDocument/2006/relationships">
+  <p:cSld>
+    <p:bg>
+      <p:bgRef idx="1001">
+        <a:schemeClr val="bg1"/>
+      </p:bgRef>
+    </p:bg>
+    <p:spTree>
+      <p:nvGrpSpPr>
+        <p:cNvPr id="1" name=""/>
+        <p:cNvGrpSpPr/>
+        <p:nvPr/>
+      </p:nvGrpSpPr>
+      <p:grpSpPr>
+        <a:xfrm>
+          <a:off x="0" y="0"/>
+          <a:ext cx="0" cy="0"/>
+          <a:chOff x="0" y="0"/>
+          <a:chExt cx="0" cy="0"/>
+        </a:xfrm>
+      </p:grpSpPr>
+      <p:sp>
+        <p:nvSpPr>
+          <p:cNvPr id="2" name="Header Placeholder 1"/>
+          <p:cNvSpPr>
+            <a:spLocks noGrp="1"/>
+          </p:cNvSpPr>
+          <p:nvPr>
+            <p:ph type="hdr" sz="quarter"/>
+          </p:nvPr>
+        </p:nvSpPr>
+        <p:spPr>
+          <a:xfrm>
+            <a:off x="0" y="0"/>
+            <a:ext cx="2971800" cy="457200"/>
+          </a:xfrm>
+          <a:prstGeom prst="rect">
+            <a:avLst/>
+          </a:prstGeom>
+        </p:spPr>
+        <p:txBody>
+          <a:bodyPr vert="horz" lIns="91440" tIns="45720" rIns="91440" bIns="45720" rtlCol="0"/>
+          <a:lstStyle>
+            <a:lvl1pPr algn="l">
+              <a:defRPr sz="1200"/>
+            </a:lvl1pPr>
+          </a:lstStyle>
+          <a:p>
+            <a:endParaRPr lang="en-US"/>
+          </a:p>
+        </p:txBody>
+      </p:sp>
+      <p:sp>
+        <p:nvSpPr>
+          <p:cNvPr id="3" name="Date Placeholder 2"/>
+          <p:cNvSpPr>
+            <a:spLocks noGrp="1"/>
+          </p:cNvSpPr>
+          <p:nvPr>
+            <p:ph type="dt" idx="1"/>
+          </p:nvPr>
+        </p:nvSpPr>
+        <p:spPr>
+          <a:xfrm>
+            <a:off x="3884613" y="0"/>
+            <a:ext cx="2971800" cy="457200"/>
+          </a:xfrm>
+          <a:prstGeom prst="rect">
+            <a:avLst/>
+          </a:prstGeom>
+        </p:spPr>
+        <p:txBody>
+          <a:bodyPr vert="horz" lIns="91440" tIns="45720" rIns="91440" bIns="45720" rtlCol="0"/>
+          <a:lstStyle>
+            <a:lvl1pPr algn="r">
+              <a:defRPr sz="1200"/>
+            </a:lvl1pPr>
+          </a:lstStyle>
+          <a:p>
+            <a:fld id="{0F89C1C7-3DCD-1040-A9CF-14679D8B5DDD}" type="datetimeFigureOut">
+              <a:rPr lang="en-US" smtClean="0"/>
+              <a:t>10/17/16</a:t>
+            </a:fld>
+            <a:endParaRPr lang="en-US"/>
+          </a:p>
+        </p:txBody>
+      </p:sp>
+      <p:sp>
+        <p:nvSpPr>
+          <p:cNvPr id="4" name="Slide Image Placeholder 3"/>
+          <p:cNvSpPr>
+            <a:spLocks noGrp="1" noRot="1" noChangeAspect="1"/>
+          </p:cNvSpPr>
+          <p:nvPr>
+            <p:ph type="sldImg" idx="2"/>
+          </p:nvPr>
+        </p:nvSpPr>
+        <p:spPr>
+          <a:xfrm>
+            <a:off x="1143000" y="685800"/>
+            <a:ext cx="4572000" cy="3429000"/>
+          </a:xfrm>
+          <a:prstGeom prst="rect">
+            <a:avLst/>
+          </a:prstGeom>
+          <a:noFill/>
+          <a:ln w="12700">
+            <a:solidFill>
+              <a:prstClr val="black"/>
+            </a:solidFill>
+          </a:ln>
+        </p:spPr>
+        <p:txBody>
+          <a:bodyPr vert="horz" lIns="91440" tIns="45720" rIns="91440" bIns="45720" rtlCol="0" anchor="ctr"/>
+          <a:lstStyle/>
+          <a:p>
+            <a:endParaRPr lang="en-US"/>
+          </a:p>
+        </p:txBody>
+      </p:sp>
+      <p:sp>
+        <p:nvSpPr>
+          <p:cNvPr id="5" name="Notes Placeholder 4"/>
+          <p:cNvSpPr>
+            <a:spLocks noGrp="1"/>
+          </p:cNvSpPr>
+          <p:nvPr>
+            <p:ph type="body" sz="quarter" idx="3"/>
+          </p:nvPr>
+        </p:nvSpPr>
+        <p:spPr>
+          <a:xfrm>
+            <a:off x="685800" y="4343400"/>
+            <a:ext cx="5486400" cy="4114800"/>
+          </a:xfrm>
+          <a:prstGeom prst="rect">
+            <a:avLst/>
+          </a:prstGeom>
+        </p:spPr>
+        <p:txBody>
+          <a:bodyPr vert="horz" lIns="91440" tIns="45720" rIns="91440" bIns="45720" rtlCol="0"/>
+          <a:lstStyle/>
+          <a:p>
+            <a:pPr lvl="0"/>
+            <a:r>
+              <a:rPr lang="en-US" smtClean="0"/>
+              <a:t>Click to edit Master text styles</a:t>
+            </a:r>
+          </a:p>
+          <a:p>
+            <a:pPr lvl="1"/>
+            <a:r>
+              <a:rPr lang="en-US" smtClean="0"/>
+              <a:t>Second level</a:t>
+            </a:r>
+          </a:p>
+          <a:p>
+            <a:pPr lvl="2"/>
+            <a:r>
+              <a:rPr lang="en-US" smtClean="0"/>
+              <a:t>Third level</a:t>
+            </a:r>
+          </a:p>
+          <a:p>
+            <a:pPr lvl="3"/>
+            <a:r>
+              <a:rPr lang="en-US" smtClean="0"/>
+              <a:t>Fourth level</a:t>
+            </a:r>
+          </a:p>
+          <a:p>
+            <a:pPr lvl="4"/>
+            <a:r>
+              <a:rPr lang="en-US" smtClean="0"/>
+              <a:t>Fifth level</a:t>
+            </a:r>
+            <a:endParaRPr lang="en-US"/>
+          </a:p>
+        </p:txBody>
+      </p:sp>
+      <p:sp>
+        <p:nvSpPr>
+          <p:cNvPr id="6" name="Footer Placeholder 5"/>
+          <p:cNvSpPr>
+            <a:spLocks noGrp="1"/>
+          </p:cNvSpPr>
+          <p:nvPr>
+            <p:ph type="ftr" sz="quarter" idx="4"/>
+          </p:nvPr>
+        </p:nvSpPr>
+        <p:spPr>
+          <a:xfrm>
+            <a:off x="0" y="8685213"/>
+            <a:ext cx="2971800" cy="457200"/>
+          </a:xfrm>
+          <a:prstGeom prst="rect">
+            <a:avLst/>
+          </a:prstGeom>
+        </p:spPr>
+        <p:txBody>
+          <a:bodyPr vert="horz" lIns="91440" tIns="45720" rIns="91440" bIns="45720" rtlCol="0" anchor="b"/>
+          <a:lstStyle>
+            <a:lvl1pPr algn="l">
+              <a:defRPr sz="1200"/>
+            </a:lvl1pPr>
+          </a:lstStyle>
+          <a:p>
+            <a:endParaRPr lang="en-US"/>
+          </a:p>
+        </p:txBody>
+      </p:sp>
+      <p:sp>
+        <p:nvSpPr>
+          <p:cNvPr id="7" name="Slide Number Placeholder 6"/>
+          <p:cNvSpPr>
+            <a:spLocks noGrp="1"/>
+          </p:cNvSpPr>
+          <p:nvPr>
+            <p:ph type="sldNum" sz="quarter" idx="5"/>
+          </p:nvPr>
+        </p:nvSpPr>
+        <p:spPr>
+          <a:xfrm>
+            <a:off x="3884613" y="8685213"/>
+            <a:ext cx="2971800" cy="457200"/>
+          </a:xfrm>
+          <a:prstGeom prst="rect">
+            <a:avLst/>
+          </a:prstGeom>
+        </p:spPr>
+        <p:txBody>
+          <a:bodyPr vert="horz" lIns="91440" tIns="45720" rIns="91440" bIns="45720" rtlCol="0" anchor="b"/>
+          <a:lstStyle>
+            <a:lvl1pPr algn="r">
+              <a:defRPr sz="1200"/>
+            </a:lvl1pPr>
+          </a:lstStyle>
+          <a:p>
+            <a:fld id="{BB5E49A5-4136-284D-997B-48E1D791AD67}" type="slidenum">
+              <a:rPr lang="en-US" smtClean="0"/>
+              <a:t>‹#›</a:t>
+            </a:fld>
+            <a:endParaRPr lang="en-US"/>
+          </a:p>
+        </p:txBody>
+      </p:sp>
+    </p:spTree>
+    <p:extLst>
+      <p:ext uri="{BB962C8B-B14F-4D97-AF65-F5344CB8AC3E}">
+        <p14:creationId xmlns:p14="http://schemas.microsoft.com/office/powerpoint/2010/main" val="2623252185"/>
+      </p:ext>
+    </p:extLst>
+  </p:cSld>
+  <p:clrMap bg1="lt1" tx1="dk1" bg2="lt2" tx2="dk2" accent1="accent1" accent2="accent2" accent3="accent3" accent4="accent4" accent5="accent5" accent6="accent6" hlink="hlink" folHlink="folHlink"/>
+  <p:notesStyle>
+    <a:lvl1pPr marL="0" algn="l" defTabSz="457200" rtl="0" eaLnBrk="1" latinLnBrk="0" hangingPunct="1">
+      <a:defRPr sz="1200" kern="1200">
+        <a:solidFill>
+          <a:schemeClr val="tx1"/>
+        </a:solidFill>
+        <a:latin typeface="+mn-lt"/>
+        <a:ea typeface="+mn-ea"/>
+        <a:cs typeface="+mn-cs"/>
+      </a:defRPr>
+    </a:lvl1pPr>
+    <a:lvl2pPr marL="457200" algn="l" defTabSz="457200" rtl="0" eaLnBrk="1" latinLnBrk="0" hangingPunct="1">
+      <a:defRPr sz="1200" kern="1200">
+        <a:solidFill>
+          <a:schemeClr val="tx1"/>
+        </a:solidFill>
+        <a:latin typeface="+mn-lt"/>
+        <a:ea typeface="+mn-ea"/>
+        <a:cs typeface="+mn-cs"/>
+      </a:defRPr>
+    </a:lvl2pPr>
+    <a:lvl3pPr marL="914400" algn="l" defTabSz="457200" rtl="0" eaLnBrk="1" latinLnBrk="0" hangingPunct="1">
+      <a:defRPr sz="1200" kern="1200">
+        <a:solidFill>
+          <a:schemeClr val="tx1"/>
+        </a:solidFill>
+        <a:latin typeface="+mn-lt"/>
+        <a:ea typeface="+mn-ea"/>
+        <a:cs typeface="+mn-cs"/>
+      </a:defRPr>
+    </a:lvl3pPr>
+    <a:lvl4pPr marL="1371600" algn="l" defTabSz="457200" rtl="0" eaLnBrk="1" latinLnBrk="0" hangingPunct="1">
+      <a:defRPr sz="1200" kern="1200">
+        <a:solidFill>
+          <a:schemeClr val="tx1"/>
+        </a:solidFill>
+        <a:latin typeface="+mn-lt"/>
+        <a:ea typeface="+mn-ea"/>
+        <a:cs typeface="+mn-cs"/>
+      </a:defRPr>
+    </a:lvl4pPr>
+    <a:lvl5pPr marL="1828800" algn="l" defTabSz="457200" rtl="0" eaLnBrk="1" latinLnBrk="0" hangingPunct="1">
+      <a:defRPr sz="1200" kern="1200">
+        <a:solidFill>
+          <a:schemeClr val="tx1"/>
+        </a:solidFill>
+        <a:latin typeface="+mn-lt"/>
+        <a:ea typeface="+mn-ea"/>
+        <a:cs typeface="+mn-cs"/>
+      </a:defRPr>
+    </a:lvl5pPr>
+    <a:lvl6pPr marL="2286000" algn="l" defTabSz="457200" rtl="0" eaLnBrk="1" latinLnBrk="0" hangingPunct="1">
+      <a:defRPr sz="1200" kern="1200">
+        <a:solidFill>
+          <a:schemeClr val="tx1"/>
+        </a:solidFill>
+        <a:latin typeface="+mn-lt"/>
+        <a:ea typeface="+mn-ea"/>
+        <a:cs typeface="+mn-cs"/>
+      </a:defRPr>
+    </a:lvl6pPr>
+    <a:lvl7pPr marL="2743200" algn="l" defTabSz="457200" rtl="0" eaLnBrk="1" latinLnBrk="0" hangingPunct="1">
+      <a:defRPr sz="1200" kern="1200">
+        <a:solidFill>
+          <a:schemeClr val="tx1"/>
+        </a:solidFill>
+        <a:latin typeface="+mn-lt"/>
+        <a:ea typeface="+mn-ea"/>
+        <a:cs typeface="+mn-cs"/>
+      </a:defRPr>
+    </a:lvl7pPr>
+    <a:lvl8pPr marL="3200400" algn="l" defTabSz="457200" rtl="0" eaLnBrk="1" latinLnBrk="0" hangingPunct="1">
+      <a:defRPr sz="1200" kern="1200">
+        <a:solidFill>
+          <a:schemeClr val="tx1"/>
+        </a:solidFill>
+        <a:latin typeface="+mn-lt"/>
+        <a:ea typeface="+mn-ea"/>
+        <a:cs typeface="+mn-cs"/>
+      </a:defRPr>
+    </a:lvl8pPr>
+    <a:lvl9pPr marL="3657600" algn="l" defTabSz="457200" rtl="0" eaLnBrk="1" latinLnBrk="0" hangingPunct="1">
+      <a:defRPr sz="1200" kern="1200">
+        <a:solidFill>
+          <a:schemeClr val="tx1"/>
+        </a:solidFill>
+        <a:latin typeface="+mn-lt"/>
+        <a:ea typeface="+mn-ea"/>
+        <a:cs typeface="+mn-cs"/>
+      </a:defRPr>
+    </a:lvl9pPr>
+  </p:notesStyle>
+</p:notesMaster>
+</file>
+
+<file path=ppt/notesSlides/notesSlide1.xml><?xml version="1.0" encoding="utf-8"?>
+<p:notes xmlns:a="http://schemas.openxmlformats.org/drawingml/2006/main" xmlns:p="http://schemas.openxmlformats.org/presentationml/2006/main" xmlns:r="http://schemas.openxmlformats.org/officeDocument/2006/relationships">
+  <p:cSld>
+    <p:spTree>
+      <p:nvGrpSpPr>
+        <p:cNvPr id="1" name=""/>
+        <p:cNvGrpSpPr/>
+        <p:nvPr/>
+      </p:nvGrpSpPr>
+      <p:grpSpPr>
+        <a:xfrm>
+          <a:off x="0" y="0"/>
+          <a:ext cx="0" cy="0"/>
+          <a:chOff x="0" y="0"/>
+          <a:chExt cx="0" cy="0"/>
+        </a:xfrm>
+      </p:grpSpPr>
+      <p:sp>
+        <p:nvSpPr>
+          <p:cNvPr id="2" name="Slide Image Placeholder 1"/>
+          <p:cNvSpPr>
+            <a:spLocks noGrp="1"/>
+          </p:cNvSpPr>
+          <p:nvPr>
+            <p:ph type="sldImg" idx="2"/>
+          </p:nvPr>
+        </p:nvSpPr>
+        <p:spPr/>
+      </p:sp>
+      <p:sp>
+        <p:nvSpPr>
+          <p:cNvPr id="3" name="Notes Placeholder 2"/>
+          <p:cNvSpPr>
+            <a:spLocks noGrp="1"/>
+          </p:cNvSpPr>
+          <p:nvPr>
+            <p:ph type="body" idx="3" sz="quarter"/>
+          </p:nvPr>
+        </p:nvSpPr>
+        <p:spPr/>
+        <p:txBody>
+          <a:bodyPr/>
+          <a:lstStyle/>
+          <a:p>
+            <a:r>
+              <a:t>[LỜI THOẠI THUYẾT TRÌNH / SPEAKER NOTES]</a:t>
+            </a:r>
+          </a:p>
+          <a:p>
+            <a:r>
+              <a:t>🇻🇳 Tiếng Việt:</a:t>
+            </a:r>
+          </a:p>
+          <a:p>
+            <a:r>
+              <a:t>"Kính chào Quý vị. Hôm nay tôi xin báo cáo Hệ thống IT Inventory của PT. Trax Apparel Indonesia theo Thông tư PER-24/BC/2023. Hệ thống đảm bảo 3 điểm cốt lõi: Tích hợp trực tiếp ERP Kế toán AXDB, lưu trữ dữ liệu trên 2 năm, và chuẩn hóa mã hàng khớp 100% với Tờ khai Hải quan."</a:t>
+            </a:r>
+          </a:p>
+          <a:p/>
+          <a:p>
+            <a:r>
+              <a:t>🇬🇧 English:</a:t>
+            </a:r>
+          </a:p>
+          <a:p>
+            <a:r>
+              <a:t>"Good morning/afternoon. Today I present our IT Inventory system for PT. Trax Apparel Indonesia under Regulation PER-24/BC/2023. Our system fulfills 3 core pillars: Direct integration with our AXDB Accounting ERP, storing data for over 2 years, and 100% standardized item codes matching Customs declarations." </a:t>
+            </a:r>
+          </a:p>
+        </p:txBody>
+      </p:sp>
+      <p:sp>
+        <p:nvSpPr>
+          <p:cNvPr id="4" name="Slide Number Placeholder 3"/>
+          <p:cNvSpPr>
+            <a:spLocks noGrp="1"/>
+          </p:cNvSpPr>
+          <p:nvPr>
+            <p:ph type="sldNum" idx="5" sz="quarter"/>
+          </p:nvPr>
+        </p:nvSpPr>
+        <p:spPr/>
+      </p:sp>
+    </p:spTree>
+  </p:cSld>
+  <p:clrMapOvr>
+    <a:masterClrMapping/>
+  </p:clrMapOvr>
+</p:notes>
+</file>
+
+<file path=ppt/notesSlides/notesSlide2.xml><?xml version="1.0" encoding="utf-8"?>
+<p:notes xmlns:a="http://schemas.openxmlformats.org/drawingml/2006/main" xmlns:p="http://schemas.openxmlformats.org/presentationml/2006/main" xmlns:r="http://schemas.openxmlformats.org/officeDocument/2006/relationships">
+  <p:cSld>
+    <p:spTree>
+      <p:nvGrpSpPr>
+        <p:cNvPr id="1" name=""/>
+        <p:cNvGrpSpPr/>
+        <p:nvPr/>
+      </p:nvGrpSpPr>
+      <p:grpSpPr>
+        <a:xfrm>
+          <a:off x="0" y="0"/>
+          <a:ext cx="0" cy="0"/>
+          <a:chOff x="0" y="0"/>
+          <a:chExt cx="0" cy="0"/>
+        </a:xfrm>
+      </p:grpSpPr>
+      <p:sp>
+        <p:nvSpPr>
+          <p:cNvPr id="2" name="Slide Image Placeholder 1"/>
+          <p:cNvSpPr>
+            <a:spLocks noGrp="1"/>
+          </p:cNvSpPr>
+          <p:nvPr>
+            <p:ph type="sldImg" idx="2"/>
+          </p:nvPr>
+        </p:nvSpPr>
+        <p:spPr/>
+      </p:sp>
+      <p:sp>
+        <p:nvSpPr>
+          <p:cNvPr id="3" name="Notes Placeholder 2"/>
+          <p:cNvSpPr>
+            <a:spLocks noGrp="1"/>
+          </p:cNvSpPr>
+          <p:nvPr>
+            <p:ph type="body" idx="3" sz="quarter"/>
+          </p:nvPr>
+        </p:nvSpPr>
+        <p:spPr/>
+        <p:txBody>
+          <a:bodyPr/>
+          <a:lstStyle/>
+          <a:p>
+            <a:r>
+              <a:t>[LỜI THOẠI THUYẾT TRÌNH / SPEAKER NOTES]</a:t>
+            </a:r>
+          </a:p>
+          <a:p>
+            <a:r>
+              <a:t>🇻🇳 Tiếng Việt:</a:t>
+            </a:r>
+          </a:p>
+          <a:p>
+            <a:r>
+              <a:t>"Bài báo cáo gồm 5 phần chính: Nhập kho, Xuất kho, Biến động kho &amp; Kiểm kê, Điều chỉnh kho &amp; Cổng API, và Tích hợp Kế toán ERP."</a:t>
+            </a:r>
+          </a:p>
+          <a:p/>
+          <a:p>
+            <a:r>
+              <a:t>🇬🇧 English:</a:t>
+            </a:r>
+          </a:p>
+          <a:p>
+            <a:r>
+              <a:t>"The presentation covers 5 key modules: Inbound, Outbound, Inventory Movement &amp; Stock Opname, Adjustments &amp; API Gateway, and Enterprise ERP Integration." </a:t>
+            </a:r>
+          </a:p>
+        </p:txBody>
+      </p:sp>
+      <p:sp>
+        <p:nvSpPr>
+          <p:cNvPr id="4" name="Slide Number Placeholder 3"/>
+          <p:cNvSpPr>
+            <a:spLocks noGrp="1"/>
+          </p:cNvSpPr>
+          <p:nvPr>
+            <p:ph type="sldNum" idx="5" sz="quarter"/>
+          </p:nvPr>
+        </p:nvSpPr>
+        <p:spPr/>
+      </p:sp>
+    </p:spTree>
+  </p:cSld>
+  <p:clrMapOvr>
+    <a:masterClrMapping/>
+  </p:clrMapOvr>
+</p:notes>
+</file>
+
+<file path=ppt/notesSlides/notesSlide3.xml><?xml version="1.0" encoding="utf-8"?>
+<p:notes xmlns:a="http://schemas.openxmlformats.org/drawingml/2006/main" xmlns:p="http://schemas.openxmlformats.org/presentationml/2006/main" xmlns:r="http://schemas.openxmlformats.org/officeDocument/2006/relationships">
+  <p:cSld>
+    <p:spTree>
+      <p:nvGrpSpPr>
+        <p:cNvPr id="1" name=""/>
+        <p:cNvGrpSpPr/>
+        <p:nvPr/>
+      </p:nvGrpSpPr>
+      <p:grpSpPr>
+        <a:xfrm>
+          <a:off x="0" y="0"/>
+          <a:ext cx="0" cy="0"/>
+          <a:chOff x="0" y="0"/>
+          <a:chExt cx="0" cy="0"/>
+        </a:xfrm>
+      </p:grpSpPr>
+      <p:sp>
+        <p:nvSpPr>
+          <p:cNvPr id="2" name="Slide Image Placeholder 1"/>
+          <p:cNvSpPr>
+            <a:spLocks noGrp="1"/>
+          </p:cNvSpPr>
+          <p:nvPr>
+            <p:ph type="sldImg" idx="2"/>
+          </p:nvPr>
+        </p:nvSpPr>
+        <p:spPr/>
+      </p:sp>
+      <p:sp>
+        <p:nvSpPr>
+          <p:cNvPr id="3" name="Notes Placeholder 2"/>
+          <p:cNvSpPr>
+            <a:spLocks noGrp="1"/>
+          </p:cNvSpPr>
+          <p:nvPr>
+            <p:ph type="body" idx="3" sz="quarter"/>
+          </p:nvPr>
+        </p:nvSpPr>
+        <p:spPr/>
+        <p:txBody>
+          <a:bodyPr/>
+          <a:lstStyle/>
+          <a:p>
+            <a:r>
+              <a:t>[LỜI THOẠI THUYẾT TRÌNH / SPEAKER NOTES]</a:t>
+            </a:r>
+          </a:p>
+          <a:p>
+            <a:r>
+              <a:t>🇻🇳 Tiếng Việt:</a:t>
+            </a:r>
+          </a:p>
+          <a:p>
+            <a:r>
+              <a:t>"Về Nhập kho: Hệ thống tự động đọc và lưu trữ tờ khai nhập khẩu BC 2.0, BC 2.3, PPKEK và hóa đơn VAT. Mã hàng được chuẩn hóa và phân loại rõ nguồn gốc Nhập khẩu (Impor) hay Mua trong nước (TLDDP)."</a:t>
+            </a:r>
+          </a:p>
+          <a:p/>
+          <a:p>
+            <a:r>
+              <a:t>🇬🇧 English:</a:t>
+            </a:r>
+          </a:p>
+          <a:p>
+            <a:r>
+              <a:t>"For Inbound: The system automatically captures and archives import declarations BC 2.0, BC 2.3, PPKEK, and VAT invoices. Item codes are standardized and clearly separated by Import and Domestic (TLDDP) origins." </a:t>
+            </a:r>
+          </a:p>
+        </p:txBody>
+      </p:sp>
+      <p:sp>
+        <p:nvSpPr>
+          <p:cNvPr id="4" name="Slide Number Placeholder 3"/>
+          <p:cNvSpPr>
+            <a:spLocks noGrp="1"/>
+          </p:cNvSpPr>
+          <p:nvPr>
+            <p:ph type="sldNum" idx="5" sz="quarter"/>
+          </p:nvPr>
+        </p:nvSpPr>
+        <p:spPr/>
+      </p:sp>
+    </p:spTree>
+  </p:cSld>
+  <p:clrMapOvr>
+    <a:masterClrMapping/>
+  </p:clrMapOvr>
+</p:notes>
+</file>
+
+<file path=ppt/notesSlides/notesSlide4.xml><?xml version="1.0" encoding="utf-8"?>
+<p:notes xmlns:a="http://schemas.openxmlformats.org/drawingml/2006/main" xmlns:p="http://schemas.openxmlformats.org/presentationml/2006/main" xmlns:r="http://schemas.openxmlformats.org/officeDocument/2006/relationships">
+  <p:cSld>
+    <p:spTree>
+      <p:nvGrpSpPr>
+        <p:cNvPr id="1" name=""/>
+        <p:cNvGrpSpPr/>
+        <p:nvPr/>
+      </p:nvGrpSpPr>
+      <p:grpSpPr>
+        <a:xfrm>
+          <a:off x="0" y="0"/>
+          <a:ext cx="0" cy="0"/>
+          <a:chOff x="0" y="0"/>
+          <a:chExt cx="0" cy="0"/>
+        </a:xfrm>
+      </p:grpSpPr>
+      <p:sp>
+        <p:nvSpPr>
+          <p:cNvPr id="2" name="Slide Image Placeholder 1"/>
+          <p:cNvSpPr>
+            <a:spLocks noGrp="1"/>
+          </p:cNvSpPr>
+          <p:nvPr>
+            <p:ph type="sldImg" idx="2"/>
+          </p:nvPr>
+        </p:nvSpPr>
+        <p:spPr/>
+      </p:sp>
+      <p:sp>
+        <p:nvSpPr>
+          <p:cNvPr id="3" name="Notes Placeholder 2"/>
+          <p:cNvSpPr>
+            <a:spLocks noGrp="1"/>
+          </p:cNvSpPr>
+          <p:nvPr>
+            <p:ph type="body" idx="3" sz="quarter"/>
+          </p:nvPr>
+        </p:nvSpPr>
+        <p:spPr/>
+        <p:txBody>
+          <a:bodyPr/>
+          <a:lstStyle/>
+          <a:p>
+            <a:r>
+              <a:t>[LỜI THOẠI THUYẾT TRÌNH / SPEAKER NOTES]</a:t>
+            </a:r>
+          </a:p>
+          <a:p>
+            <a:r>
+              <a:t>🇻🇳 Tiếng Việt:</a:t>
+            </a:r>
+          </a:p>
+          <a:p>
+            <a:r>
+              <a:t>"Về Xuất kho: Quản lý chứng từ xuất BC 3.0, BC 2.7 và liên kết Phiếu giao hàng Surat Jalan. Hệ thống tự động nhận diện chứng từ nội bộ CEISA và khóa nút gửi để tránh gửi nhầm lên Cổng INSW."</a:t>
+            </a:r>
+          </a:p>
+          <a:p/>
+          <a:p>
+            <a:r>
+              <a:t>🇬🇧 English:</a:t>
+            </a:r>
+          </a:p>
+          <a:p>
+            <a:r>
+              <a:t>"For Outbound: It manages export declarations BC 3.0, BC 2.7, and links Surat Jalan delivery notes. The system auto-detects internal CEISA documents and locks transmission to prevent accidental submission to INSW." </a:t>
+            </a:r>
+          </a:p>
+        </p:txBody>
+      </p:sp>
+      <p:sp>
+        <p:nvSpPr>
+          <p:cNvPr id="4" name="Slide Number Placeholder 3"/>
+          <p:cNvSpPr>
+            <a:spLocks noGrp="1"/>
+          </p:cNvSpPr>
+          <p:nvPr>
+            <p:ph type="sldNum" idx="5" sz="quarter"/>
+          </p:nvPr>
+        </p:nvSpPr>
+        <p:spPr/>
+      </p:sp>
+    </p:spTree>
+  </p:cSld>
+  <p:clrMapOvr>
+    <a:masterClrMapping/>
+  </p:clrMapOvr>
+</p:notes>
+</file>
+
+<file path=ppt/notesSlides/notesSlide5.xml><?xml version="1.0" encoding="utf-8"?>
+<p:notes xmlns:a="http://schemas.openxmlformats.org/drawingml/2006/main" xmlns:p="http://schemas.openxmlformats.org/presentationml/2006/main" xmlns:r="http://schemas.openxmlformats.org/officeDocument/2006/relationships">
+  <p:cSld>
+    <p:spTree>
+      <p:nvGrpSpPr>
+        <p:cNvPr id="1" name=""/>
+        <p:cNvGrpSpPr/>
+        <p:nvPr/>
+      </p:nvGrpSpPr>
+      <p:grpSpPr>
+        <a:xfrm>
+          <a:off x="0" y="0"/>
+          <a:ext cx="0" cy="0"/>
+          <a:chOff x="0" y="0"/>
+          <a:chExt cx="0" cy="0"/>
+        </a:xfrm>
+      </p:grpSpPr>
+      <p:sp>
+        <p:nvSpPr>
+          <p:cNvPr id="2" name="Slide Image Placeholder 1"/>
+          <p:cNvSpPr>
+            <a:spLocks noGrp="1"/>
+          </p:cNvSpPr>
+          <p:nvPr>
+            <p:ph type="sldImg" idx="2"/>
+          </p:nvPr>
+        </p:nvSpPr>
+        <p:spPr/>
+      </p:sp>
+      <p:sp>
+        <p:nvSpPr>
+          <p:cNvPr id="3" name="Notes Placeholder 2"/>
+          <p:cNvSpPr>
+            <a:spLocks noGrp="1"/>
+          </p:cNvSpPr>
+          <p:nvPr>
+            <p:ph type="body" idx="3" sz="quarter"/>
+          </p:nvPr>
+        </p:nvSpPr>
+        <p:spPr/>
+        <p:txBody>
+          <a:bodyPr/>
+          <a:lstStyle/>
+          <a:p>
+            <a:r>
+              <a:t>[LỜI THOẠI THUYẾT TRÌNH / SPEAKER NOTES]</a:t>
+            </a:r>
+          </a:p>
+          <a:p>
+            <a:r>
+              <a:t>🇻🇳 Tiếng Việt:</a:t>
+            </a:r>
+          </a:p>
+          <a:p>
+            <a:r>
+              <a:t>"Về Biến động kho: Báo cáo đầy đủ 7 danh mục vật tư theo luật định. Chúng tôi áp dụng chốt sổ ca đêm lúc 5:00 AM để số liệu hệ thống luôn khớp 100% với kiểm kê bãi kho thực tế của nhà máy."</a:t>
+            </a:r>
+          </a:p>
+          <a:p/>
+          <a:p>
+            <a:r>
+              <a:t>🇬🇧 English:</a:t>
+            </a:r>
+          </a:p>
+          <a:p>
+            <a:r>
+              <a:t>"For Inventory Movement: It covers all 7 mandatory material categories. We apply a 5:00 AM Night Shift Cutoff so system figures always match physical warehouse stock 100%." </a:t>
+            </a:r>
+          </a:p>
+        </p:txBody>
+      </p:sp>
+      <p:sp>
+        <p:nvSpPr>
+          <p:cNvPr id="4" name="Slide Number Placeholder 3"/>
+          <p:cNvSpPr>
+            <a:spLocks noGrp="1"/>
+          </p:cNvSpPr>
+          <p:nvPr>
+            <p:ph type="sldNum" idx="5" sz="quarter"/>
+          </p:nvPr>
+        </p:nvSpPr>
+        <p:spPr/>
+      </p:sp>
+    </p:spTree>
+  </p:cSld>
+  <p:clrMapOvr>
+    <a:masterClrMapping/>
+  </p:clrMapOvr>
+</p:notes>
+</file>
+
+<file path=ppt/notesSlides/notesSlide6.xml><?xml version="1.0" encoding="utf-8"?>
+<p:notes xmlns:a="http://schemas.openxmlformats.org/drawingml/2006/main" xmlns:p="http://schemas.openxmlformats.org/presentationml/2006/main" xmlns:r="http://schemas.openxmlformats.org/officeDocument/2006/relationships">
+  <p:cSld>
+    <p:spTree>
+      <p:nvGrpSpPr>
+        <p:cNvPr id="1" name=""/>
+        <p:cNvGrpSpPr/>
+        <p:nvPr/>
+      </p:nvGrpSpPr>
+      <p:grpSpPr>
+        <a:xfrm>
+          <a:off x="0" y="0"/>
+          <a:ext cx="0" cy="0"/>
+          <a:chOff x="0" y="0"/>
+          <a:chExt cx="0" cy="0"/>
+        </a:xfrm>
+      </p:grpSpPr>
+      <p:sp>
+        <p:nvSpPr>
+          <p:cNvPr id="2" name="Slide Image Placeholder 1"/>
+          <p:cNvSpPr>
+            <a:spLocks noGrp="1"/>
+          </p:cNvSpPr>
+          <p:nvPr>
+            <p:ph type="sldImg" idx="2"/>
+          </p:nvPr>
+        </p:nvSpPr>
+        <p:spPr/>
+      </p:sp>
+      <p:sp>
+        <p:nvSpPr>
+          <p:cNvPr id="3" name="Notes Placeholder 2"/>
+          <p:cNvSpPr>
+            <a:spLocks noGrp="1"/>
+          </p:cNvSpPr>
+          <p:nvPr>
+            <p:ph type="body" idx="3" sz="quarter"/>
+          </p:nvPr>
+        </p:nvSpPr>
+        <p:spPr/>
+        <p:txBody>
+          <a:bodyPr/>
+          <a:lstStyle/>
+          <a:p>
+            <a:r>
+              <a:t>[LỜI THOẠI THUYẾT TRÌNH / SPEAKER NOTES]</a:t>
+            </a:r>
+          </a:p>
+          <a:p>
+            <a:r>
+              <a:t>🇻🇳 Tiếng Việt:</a:t>
+            </a:r>
+          </a:p>
+          <a:p>
+            <a:r>
+              <a:t>"Về Điều chỉnh kho: Mọi chênh lệch kiểm kê được ghi nhận rõ ràng, lưu vết lịch sử không thể sửa xóa trên 2 năm, và kết nối truyền dữ liệu tự động API 24/7 trực tiếp tới Hải quan."</a:t>
+            </a:r>
+          </a:p>
+          <a:p/>
+          <a:p>
+            <a:r>
+              <a:t>🇬🇧 English:</a:t>
+            </a:r>
+          </a:p>
+          <a:p>
+            <a:r>
+              <a:t>"For Adjustments: All variances are transparently logged with an immutable audit trail over 2 years, and automatically transmitted 24/7 via API directly to Customs." </a:t>
+            </a:r>
+          </a:p>
+        </p:txBody>
+      </p:sp>
+      <p:sp>
+        <p:nvSpPr>
+          <p:cNvPr id="4" name="Slide Number Placeholder 3"/>
+          <p:cNvSpPr>
+            <a:spLocks noGrp="1"/>
+          </p:cNvSpPr>
+          <p:nvPr>
+            <p:ph type="sldNum" idx="5" sz="quarter"/>
+          </p:nvPr>
+        </p:nvSpPr>
+        <p:spPr/>
+      </p:sp>
+    </p:spTree>
+  </p:cSld>
+  <p:clrMapOvr>
+    <a:masterClrMapping/>
+  </p:clrMapOvr>
+</p:notes>
+</file>
+
+<file path=ppt/notesSlides/notesSlide7.xml><?xml version="1.0" encoding="utf-8"?>
+<p:notes xmlns:a="http://schemas.openxmlformats.org/drawingml/2006/main" xmlns:p="http://schemas.openxmlformats.org/presentationml/2006/main" xmlns:r="http://schemas.openxmlformats.org/officeDocument/2006/relationships">
+  <p:cSld>
+    <p:spTree>
+      <p:nvGrpSpPr>
+        <p:cNvPr id="1" name=""/>
+        <p:cNvGrpSpPr/>
+        <p:nvPr/>
+      </p:nvGrpSpPr>
+      <p:grpSpPr>
+        <a:xfrm>
+          <a:off x="0" y="0"/>
+          <a:ext cx="0" cy="0"/>
+          <a:chOff x="0" y="0"/>
+          <a:chExt cx="0" cy="0"/>
+        </a:xfrm>
+      </p:grpSpPr>
+      <p:sp>
+        <p:nvSpPr>
+          <p:cNvPr id="2" name="Slide Image Placeholder 1"/>
+          <p:cNvSpPr>
+            <a:spLocks noGrp="1"/>
+          </p:cNvSpPr>
+          <p:nvPr>
+            <p:ph type="sldImg" idx="2"/>
+          </p:nvPr>
+        </p:nvSpPr>
+        <p:spPr/>
+      </p:sp>
+      <p:sp>
+        <p:nvSpPr>
+          <p:cNvPr id="3" name="Notes Placeholder 2"/>
+          <p:cNvSpPr>
+            <a:spLocks noGrp="1"/>
+          </p:cNvSpPr>
+          <p:nvPr>
+            <p:ph type="body" idx="3" sz="quarter"/>
+          </p:nvPr>
+        </p:nvSpPr>
+        <p:spPr/>
+        <p:txBody>
+          <a:bodyPr/>
+          <a:lstStyle/>
+          <a:p>
+            <a:r>
+              <a:t>[LỜI THOẠI THUYẾT TRÌNH / SPEAKER NOTES]</a:t>
+            </a:r>
+          </a:p>
+          <a:p>
+            <a:r>
+              <a:t>🇻🇳 Tiếng Việt:</a:t>
+            </a:r>
+          </a:p>
+          <a:p>
+            <a:r>
+              <a:t>"Về Tích hợp Kế toán: IT Inventory chạy trực tiếp trên CSDL Kế toán AXDB ERP của nhà máy, không dùng file Excel ngoài. Master Data được phân loại chuẩn theo 8 nhóm INSW và mã HS Code, giúp số liệu Hải quan và Báo cáo Thuế luôn trùng khớp."</a:t>
+            </a:r>
+          </a:p>
+          <a:p/>
+          <a:p>
+            <a:r>
+              <a:t>🇬🇧 English:</a:t>
+            </a:r>
+          </a:p>
+          <a:p>
+            <a:r>
+              <a:t>"For ERP Integration: IT Inventory runs directly inside our plant's AXDB ERP database, not external Excel sheets. Master Data is classified under 8 INSW categories and HS Codes, ensuring full alignment between Customs and Tax records." </a:t>
+            </a:r>
+          </a:p>
+        </p:txBody>
+      </p:sp>
+      <p:sp>
+        <p:nvSpPr>
+          <p:cNvPr id="4" name="Slide Number Placeholder 3"/>
+          <p:cNvSpPr>
+            <a:spLocks noGrp="1"/>
+          </p:cNvSpPr>
+          <p:nvPr>
+            <p:ph type="sldNum" idx="5" sz="quarter"/>
+          </p:nvPr>
+        </p:nvSpPr>
+        <p:spPr/>
+      </p:sp>
+    </p:spTree>
+  </p:cSld>
+  <p:clrMapOvr>
+    <a:masterClrMapping/>
+  </p:clrMapOvr>
+</p:notes>
+</file>
+
+<file path=ppt/notesSlides/notesSlide8.xml><?xml version="1.0" encoding="utf-8"?>
+<p:notes xmlns:a="http://schemas.openxmlformats.org/drawingml/2006/main" xmlns:p="http://schemas.openxmlformats.org/presentationml/2006/main" xmlns:r="http://schemas.openxmlformats.org/officeDocument/2006/relationships">
+  <p:cSld>
+    <p:spTree>
+      <p:nvGrpSpPr>
+        <p:cNvPr id="1" name=""/>
+        <p:cNvGrpSpPr/>
+        <p:nvPr/>
+      </p:nvGrpSpPr>
+      <p:grpSpPr>
+        <a:xfrm>
+          <a:off x="0" y="0"/>
+          <a:ext cx="0" cy="0"/>
+          <a:chOff x="0" y="0"/>
+          <a:chExt cx="0" cy="0"/>
+        </a:xfrm>
+      </p:grpSpPr>
+      <p:sp>
+        <p:nvSpPr>
+          <p:cNvPr id="2" name="Slide Image Placeholder 1"/>
+          <p:cNvSpPr>
+            <a:spLocks noGrp="1"/>
+          </p:cNvSpPr>
+          <p:nvPr>
+            <p:ph type="sldImg" idx="2"/>
+          </p:nvPr>
+        </p:nvSpPr>
+        <p:spPr/>
+      </p:sp>
+      <p:sp>
+        <p:nvSpPr>
+          <p:cNvPr id="3" name="Notes Placeholder 2"/>
+          <p:cNvSpPr>
+            <a:spLocks noGrp="1"/>
+          </p:cNvSpPr>
+          <p:nvPr>
+            <p:ph type="body" idx="3" sz="quarter"/>
+          </p:nvPr>
+        </p:nvSpPr>
+        <p:spPr/>
+        <p:txBody>
+          <a:bodyPr/>
+          <a:lstStyle/>
+          <a:p>
+            <a:r>
+              <a:t>[LỜI THOẠI THUYẾT TRÌNH / SPEAKER NOTES]</a:t>
+            </a:r>
+          </a:p>
+          <a:p>
+            <a:r>
+              <a:t>🇻🇳 Tiếng Việt:</a:t>
+            </a:r>
+          </a:p>
+          <a:p>
+            <a:r>
+              <a:t>"Đó là phần trình bày tóm tắt về Hệ thống IT Inventory. Xin trân trọng kính mời Quý vị đặt câu hỏi."</a:t>
+            </a:r>
+          </a:p>
+          <a:p/>
+          <a:p>
+            <a:r>
+              <a:t>🇬🇧 English:</a:t>
+            </a:r>
+          </a:p>
+          <a:p>
+            <a:r>
+              <a:t>"That summarizes our IT Inventory presentation. We now welcome your questions and comments." </a:t>
+            </a:r>
+          </a:p>
+        </p:txBody>
+      </p:sp>
+      <p:sp>
+        <p:nvSpPr>
+          <p:cNvPr id="4" name="Slide Number Placeholder 3"/>
+          <p:cNvSpPr>
+            <a:spLocks noGrp="1"/>
+          </p:cNvSpPr>
+          <p:nvPr>
+            <p:ph type="sldNum" idx="5" sz="quarter"/>
+          </p:nvPr>
+        </p:nvSpPr>
+        <p:spPr/>
+      </p:sp>
+    </p:spTree>
+  </p:cSld>
+  <p:clrMapOvr>
+    <a:masterClrMapping/>
+  </p:clrMapOvr>
+</p:notes>
+</file>
+
+<file path=ppt/notesSlides/notesSlide9.xml><?xml version="1.0" encoding="utf-8"?>
+<p:notes xmlns:a="http://schemas.openxmlformats.org/drawingml/2006/main" xmlns:p="http://schemas.openxmlformats.org/presentationml/2006/main" xmlns:r="http://schemas.openxmlformats.org/officeDocument/2006/relationships">
+  <p:cSld>
+    <p:spTree>
+      <p:nvGrpSpPr>
+        <p:cNvPr id="1" name=""/>
+        <p:cNvGrpSpPr/>
+        <p:nvPr/>
+      </p:nvGrpSpPr>
+      <p:grpSpPr>
+        <a:xfrm>
+          <a:off x="0" y="0"/>
+          <a:ext cx="0" cy="0"/>
+          <a:chOff x="0" y="0"/>
+          <a:chExt cx="0" cy="0"/>
+        </a:xfrm>
+      </p:grpSpPr>
+      <p:sp>
+        <p:nvSpPr>
+          <p:cNvPr id="2" name="Slide Image Placeholder 1"/>
+          <p:cNvSpPr>
+            <a:spLocks noGrp="1"/>
+          </p:cNvSpPr>
+          <p:nvPr>
+            <p:ph type="sldImg" idx="2"/>
+          </p:nvPr>
+        </p:nvSpPr>
+        <p:spPr/>
+      </p:sp>
+      <p:sp>
+        <p:nvSpPr>
+          <p:cNvPr id="3" name="Notes Placeholder 2"/>
+          <p:cNvSpPr>
+            <a:spLocks noGrp="1"/>
+          </p:cNvSpPr>
+          <p:nvPr>
+            <p:ph type="body" idx="3" sz="quarter"/>
+          </p:nvPr>
+        </p:nvSpPr>
+        <p:spPr/>
+        <p:txBody>
+          <a:bodyPr/>
+          <a:lstStyle/>
+          <a:p>
+            <a:r>
+              <a:t>[LỜI THOẠI THUYẾT TRÌNH / SPEAKER NOTES]</a:t>
+            </a:r>
+          </a:p>
+          <a:p>
+            <a:r>
+              <a:t>🇻🇳 Tiếng Việt:</a:t>
+            </a:r>
+          </a:p>
+          <a:p>
+            <a:r>
+              <a:t>"Xin chân thành cảm ơn Quý vị đã lắng nghe! Khép lại bài thuyết trình. Terima kasih banyak!"</a:t>
+            </a:r>
+          </a:p>
+          <a:p/>
+          <a:p>
+            <a:r>
+              <a:t>🇬🇧 English:</a:t>
+            </a:r>
+          </a:p>
+          <a:p>
+            <a:r>
+              <a:t>"Thank you very much for your time and attention! Concluding our presentation. Terima kasih nhiều!" </a:t>
+            </a:r>
+          </a:p>
+        </p:txBody>
+      </p:sp>
+      <p:sp>
+        <p:nvSpPr>
+          <p:cNvPr id="4" name="Slide Number Placeholder 3"/>
+          <p:cNvSpPr>
+            <a:spLocks noGrp="1"/>
+          </p:cNvSpPr>
+          <p:nvPr>
+            <p:ph type="sldNum" idx="5" sz="quarter"/>
+          </p:nvPr>
+        </p:nvSpPr>
+        <p:spPr/>
+      </p:sp>
+    </p:spTree>
+  </p:cSld>
+  <p:clrMapOvr>
+    <a:masterClrMapping/>
+  </p:clrMapOvr>
+</p:notes>
 </file>
 
 <file path=ppt/slideLayouts/slideLayout1.xml><?xml version="1.0" encoding="utf-8"?>
@@ -7890,4 +9059,324 @@
   </a:objectDefaults>
   <a:extraClrSchemeLst/>
 </a:theme>
+</file>
+
+<file path=ppt/theme/theme2.xml><?xml version="1.0" encoding="utf-8"?>
+<a:theme xmlns:a="http://schemas.openxmlformats.org/drawingml/2006/main" name="Office Theme">
+  <a:themeElements>
+    <a:clrScheme name="Office">
+      <a:dk1>
+        <a:sysClr val="windowText" lastClr="000000"/>
+      </a:dk1>
+      <a:lt1>
+        <a:sysClr val="window" lastClr="FFFFFF"/>
+      </a:lt1>
+      <a:dk2>
+        <a:srgbClr val="1F497D"/>
+      </a:dk2>
+      <a:lt2>
+        <a:srgbClr val="EEECE1"/>
+      </a:lt2>
+      <a:accent1>
+        <a:srgbClr val="4F81BD"/>
+      </a:accent1>
+      <a:accent2>
+        <a:srgbClr val="C0504D"/>
+      </a:accent2>
+      <a:accent3>
+        <a:srgbClr val="9BBB59"/>
+      </a:accent3>
+      <a:accent4>
+        <a:srgbClr val="8064A2"/>
+      </a:accent4>
+      <a:accent5>
+        <a:srgbClr val="4BACC6"/>
+      </a:accent5>
+      <a:accent6>
+        <a:srgbClr val="F79646"/>
+      </a:accent6>
+      <a:hlink>
+        <a:srgbClr val="0000FF"/>
+      </a:hlink>
+      <a:folHlink>
+        <a:srgbClr val="800080"/>
+      </a:folHlink>
+    </a:clrScheme>
+    <a:fontScheme name="Office">
+      <a:majorFont>
+        <a:latin typeface="Calibri"/>
+        <a:ea typeface=""/>
+        <a:cs typeface=""/>
+        <a:font script="Jpan" typeface="ＭＳ Ｐゴシック"/>
+        <a:font script="Hang" typeface="맑은 고딕"/>
+        <a:font script="Hans" typeface="宋体"/>
+        <a:font script="Hant" typeface="新細明體"/>
+        <a:font script="Arab" typeface="Times New Roman"/>
+        <a:font script="Hebr" typeface="Times New Roman"/>
+        <a:font script="Thai" typeface="Angsana New"/>
+        <a:font script="Ethi" typeface="Nyala"/>
+        <a:font script="Beng" typeface="Vrinda"/>
+        <a:font script="Gujr" typeface="Shruti"/>
+        <a:font script="Khmr" typeface="MoolBoran"/>
+        <a:font script="Knda" typeface="Tunga"/>
+        <a:font script="Guru" typeface="Raavi"/>
+        <a:font script="Cans" typeface="Euphemia"/>
+        <a:font script="Cher" typeface="Plantagenet Cherokee"/>
+        <a:font script="Yiii" typeface="Microsoft Yi Baiti"/>
+        <a:font script="Tibt" typeface="Microsoft Himalaya"/>
+        <a:font script="Thaa" typeface="MV Boli"/>
+        <a:font script="Deva" typeface="Mangal"/>
+        <a:font script="Telu" typeface="Gautami"/>
+        <a:font script="Taml" typeface="Latha"/>
+        <a:font script="Syrc" typeface="Estrangelo Edessa"/>
+        <a:font script="Orya" typeface="Kalinga"/>
+        <a:font script="Mlym" typeface="Kartika"/>
+        <a:font script="Laoo" typeface="DokChampa"/>
+        <a:font script="Sinh" typeface="Iskoola Pota"/>
+        <a:font script="Mong" typeface="Mongolian Baiti"/>
+        <a:font script="Viet" typeface="Times New Roman"/>
+        <a:font script="Uigh" typeface="Microsoft Uighur"/>
+        <a:font script="Geor" typeface="Sylfaen"/>
+      </a:majorFont>
+      <a:minorFont>
+        <a:latin typeface="Calibri"/>
+        <a:ea typeface=""/>
+        <a:cs typeface=""/>
+        <a:font script="Jpan" typeface="ＭＳ Ｐゴシック"/>
+        <a:font script="Hang" typeface="맑은 고딕"/>
+        <a:font script="Hans" typeface="宋体"/>
+        <a:font script="Hant" typeface="新細明體"/>
+        <a:font script="Arab" typeface="Arial"/>
+        <a:font script="Hebr" typeface="Arial"/>
+        <a:font script="Thai" typeface="Cordia New"/>
+        <a:font script="Ethi" typeface="Nyala"/>
+        <a:font script="Beng" typeface="Vrinda"/>
+        <a:font script="Gujr" typeface="Shruti"/>
+        <a:font script="Khmr" typeface="DaunPenh"/>
+        <a:font script="Knda" typeface="Tunga"/>
+        <a:font script="Guru" typeface="Raavi"/>
+        <a:font script="Cans" typeface="Euphemia"/>
+        <a:font script="Cher" typeface="Plantagenet Cherokee"/>
+        <a:font script="Yiii" typeface="Microsoft Yi Baiti"/>
+        <a:font script="Tibt" typeface="Microsoft Himalaya"/>
+        <a:font script="Thaa" typeface="MV Boli"/>
+        <a:font script="Deva" typeface="Mangal"/>
+        <a:font script="Telu" typeface="Gautami"/>
+        <a:font script="Taml" typeface="Latha"/>
+        <a:font script="Syrc" typeface="Estrangelo Edessa"/>
+        <a:font script="Orya" typeface="Kalinga"/>
+        <a:font script="Mlym" typeface="Kartika"/>
+        <a:font script="Laoo" typeface="DokChampa"/>
+        <a:font script="Sinh" typeface="Iskoola Pota"/>
+        <a:font script="Mong" typeface="Mongolian Baiti"/>
+        <a:font script="Viet" typeface="Arial"/>
+        <a:font script="Uigh" typeface="Microsoft Uighur"/>
+        <a:font script="Geor" typeface="Sylfaen"/>
+      </a:minorFont>
+    </a:fontScheme>
+    <a:fmtScheme name="Office">
+      <a:fillStyleLst>
+        <a:solidFill>
+          <a:schemeClr val="phClr"/>
+        </a:solidFill>
+        <a:gradFill rotWithShape="1">
+          <a:gsLst>
+            <a:gs pos="0">
+              <a:schemeClr val="phClr">
+                <a:tint val="50000"/>
+                <a:satMod val="300000"/>
+              </a:schemeClr>
+            </a:gs>
+            <a:gs pos="35000">
+              <a:schemeClr val="phClr">
+                <a:tint val="37000"/>
+                <a:satMod val="300000"/>
+              </a:schemeClr>
+            </a:gs>
+            <a:gs pos="100000">
+              <a:schemeClr val="phClr">
+                <a:tint val="15000"/>
+                <a:satMod val="350000"/>
+              </a:schemeClr>
+            </a:gs>
+          </a:gsLst>
+          <a:lin ang="16200000" scaled="1"/>
+        </a:gradFill>
+        <a:gradFill rotWithShape="1">
+          <a:gsLst>
+            <a:gs pos="0">
+              <a:schemeClr val="phClr">
+                <a:tint val="100000"/>
+                <a:shade val="100000"/>
+                <a:satMod val="130000"/>
+              </a:schemeClr>
+            </a:gs>
+            <a:gs pos="100000">
+              <a:schemeClr val="phClr">
+                <a:tint val="50000"/>
+                <a:shade val="100000"/>
+                <a:satMod val="350000"/>
+              </a:schemeClr>
+            </a:gs>
+          </a:gsLst>
+          <a:lin ang="16200000" scaled="0"/>
+        </a:gradFill>
+      </a:fillStyleLst>
+      <a:lnStyleLst>
+        <a:ln w="9525" cap="flat" cmpd="sng" algn="ctr">
+          <a:solidFill>
+            <a:schemeClr val="phClr">
+              <a:shade val="95000"/>
+              <a:satMod val="105000"/>
+            </a:schemeClr>
+          </a:solidFill>
+          <a:prstDash val="solid"/>
+        </a:ln>
+        <a:ln w="25400" cap="flat" cmpd="sng" algn="ctr">
+          <a:solidFill>
+            <a:schemeClr val="phClr"/>
+          </a:solidFill>
+          <a:prstDash val="solid"/>
+        </a:ln>
+        <a:ln w="38100" cap="flat" cmpd="sng" algn="ctr">
+          <a:solidFill>
+            <a:schemeClr val="phClr"/>
+          </a:solidFill>
+          <a:prstDash val="solid"/>
+        </a:ln>
+      </a:lnStyleLst>
+      <a:effectStyleLst>
+        <a:effectStyle>
+          <a:effectLst>
+            <a:outerShdw blurRad="40000" dist="20000" dir="5400000" rotWithShape="0">
+              <a:srgbClr val="000000">
+                <a:alpha val="38000"/>
+              </a:srgbClr>
+            </a:outerShdw>
+          </a:effectLst>
+        </a:effectStyle>
+        <a:effectStyle>
+          <a:effectLst>
+            <a:outerShdw blurRad="40000" dist="23000" dir="5400000" rotWithShape="0">
+              <a:srgbClr val="000000">
+                <a:alpha val="35000"/>
+              </a:srgbClr>
+            </a:outerShdw>
+          </a:effectLst>
+        </a:effectStyle>
+        <a:effectStyle>
+          <a:effectLst>
+            <a:outerShdw blurRad="40000" dist="23000" dir="5400000" rotWithShape="0">
+              <a:srgbClr val="000000">
+                <a:alpha val="35000"/>
+              </a:srgbClr>
+            </a:outerShdw>
+          </a:effectLst>
+          <a:scene3d>
+            <a:camera prst="orthographicFront">
+              <a:rot lat="0" lon="0" rev="0"/>
+            </a:camera>
+            <a:lightRig rig="threePt" dir="t">
+              <a:rot lat="0" lon="0" rev="1200000"/>
+            </a:lightRig>
+          </a:scene3d>
+          <a:sp3d>
+            <a:bevelT w="63500" h="25400"/>
+          </a:sp3d>
+        </a:effectStyle>
+      </a:effectStyleLst>
+      <a:bgFillStyleLst>
+        <a:solidFill>
+          <a:schemeClr val="phClr"/>
+        </a:solidFill>
+        <a:gradFill rotWithShape="1">
+          <a:gsLst>
+            <a:gs pos="0">
+              <a:schemeClr val="phClr">
+                <a:tint val="40000"/>
+                <a:satMod val="350000"/>
+              </a:schemeClr>
+            </a:gs>
+            <a:gs pos="40000">
+              <a:schemeClr val="phClr">
+                <a:tint val="45000"/>
+                <a:shade val="99000"/>
+                <a:satMod val="350000"/>
+              </a:schemeClr>
+            </a:gs>
+            <a:gs pos="100000">
+              <a:schemeClr val="phClr">
+                <a:shade val="20000"/>
+                <a:satMod val="255000"/>
+              </a:schemeClr>
+            </a:gs>
+          </a:gsLst>
+          <a:path path="circle">
+            <a:fillToRect l="50000" t="-80000" r="50000" b="180000"/>
+          </a:path>
+        </a:gradFill>
+        <a:gradFill rotWithShape="1">
+          <a:gsLst>
+            <a:gs pos="0">
+              <a:schemeClr val="phClr">
+                <a:tint val="80000"/>
+                <a:satMod val="300000"/>
+              </a:schemeClr>
+            </a:gs>
+            <a:gs pos="100000">
+              <a:schemeClr val="phClr">
+                <a:shade val="30000"/>
+                <a:satMod val="200000"/>
+              </a:schemeClr>
+            </a:gs>
+          </a:gsLst>
+          <a:path path="circle">
+            <a:fillToRect l="50000" t="50000" r="50000" b="50000"/>
+          </a:path>
+        </a:gradFill>
+      </a:bgFillStyleLst>
+    </a:fmtScheme>
+  </a:themeElements>
+  <a:objectDefaults>
+    <a:spDef>
+      <a:spPr/>
+      <a:bodyPr/>
+      <a:lstStyle/>
+      <a:style>
+        <a:lnRef idx="1">
+          <a:schemeClr val="accent1"/>
+        </a:lnRef>
+        <a:fillRef idx="3">
+          <a:schemeClr val="accent1"/>
+        </a:fillRef>
+        <a:effectRef idx="2">
+          <a:schemeClr val="accent1"/>
+        </a:effectRef>
+        <a:fontRef idx="minor">
+          <a:schemeClr val="lt1"/>
+        </a:fontRef>
+      </a:style>
+    </a:spDef>
+    <a:lnDef>
+      <a:spPr/>
+      <a:bodyPr/>
+      <a:lstStyle/>
+      <a:style>
+        <a:lnRef idx="2">
+          <a:schemeClr val="accent1"/>
+        </a:lnRef>
+        <a:fillRef idx="0">
+          <a:schemeClr val="accent1"/>
+        </a:fillRef>
+        <a:effectRef idx="1">
+          <a:schemeClr val="accent1"/>
+        </a:effectRef>
+        <a:fontRef idx="minor">
+          <a:schemeClr val="tx1"/>
+        </a:fontRef>
+      </a:style>
+    </a:lnDef>
+  </a:objectDefaults>
+  <a:extraClrSchemeLst/>
+</a:theme>
 </file>
</xml_diff>